<commit_message>
Fix text overflow by adding a formatted metrics table to Slide 7, using word_wrap, and tightening margins
</commit_message>
<xml_diff>
--- a/6a45efcfcf7a7_IIT_Indore-HAL_Hackathon_Template.pptx
+++ b/6a45efcfcf7a7_IIT_Indore-HAL_Hackathon_Template.pptx
@@ -12066,7 +12066,7 @@
           </a:ln>
         </p:spPr>
         <p:txBody>
-          <a:bodyPr spcFirstLastPara="1" wrap="square" lIns="0" tIns="0" rIns="0" bIns="0" anchor="t" anchorCtr="0">
+          <a:bodyPr spcFirstLastPara="1" wrap="square" tIns="91440" bIns="91440" anchor="t" anchorCtr="0">
             <a:spAutoFit/>
           </a:bodyPr>
           <a:lstStyle/>
@@ -12079,7 +12079,7 @@
                 <a:spcPts val="0"/>
               </a:spcAft>
               <a:buNone/>
-              <a:defRPr sz="1800">
+              <a:defRPr sz="1100">
                 <a:solidFill>
                   <a:srgbClr val="475569"/>
                 </a:solidFill>
@@ -12087,13 +12087,13 @@
               </a:defRPr>
             </a:pPr>
             <a:r>
-              <a:t>• Goal: Monitor the state of a single-spool four-stage turbojet engine by estimating hidden component health indicators (Compressor, Combustor, Turbine health) and overall engine performance (Thrust, TSFC).</a:t>
+              <a:t>• Goal: Monitor 4-stage turbojet state by estimating hidden component health (Compressor, Combustor, Turbine) &amp; performance (Thrust, TSFC).</a:t>
             </a:r>
             <a:endParaRPr dirty="0"/>
           </a:p>
           <a:p>
             <a:pPr>
-              <a:defRPr sz="1800">
+              <a:defRPr sz="1100">
                 <a:solidFill>
                   <a:srgbClr val="475569"/>
                 </a:solidFill>
@@ -12101,12 +12101,12 @@
               </a:defRPr>
             </a:pPr>
             <a:r>
-              <a:t>• Motivation: Direct physical measurement of turbine inlet temperature (T3) and interior component state is impossible in real-time due to extreme heat and aerodynamic pressure.</a:t>
+              <a:t>• Motivation: Direct measurement of turbine inlet temperature (T3) is impossible in real-time due to extreme heat.</a:t>
             </a:r>
           </a:p>
           <a:p>
             <a:pPr>
-              <a:defRPr sz="1800">
+              <a:defRPr sz="1100">
                 <a:solidFill>
                   <a:srgbClr val="475569"/>
                 </a:solidFill>
@@ -12114,12 +12114,12 @@
               </a:defRPr>
             </a:pPr>
             <a:r>
-              <a:t>• Solution Significance: Real-time health estimation prevents catastrophic engine failures, reduces maintenance downtime, and optimizes fuel consumption.</a:t>
+              <a:t>• Significance: Real-time diagnostics prevent engine failures and optimize fuel efficiency.</a:t>
             </a:r>
           </a:p>
           <a:p>
             <a:pPr>
-              <a:defRPr sz="1800">
+              <a:defRPr sz="1100">
                 <a:solidFill>
                   <a:srgbClr val="475569"/>
                 </a:solidFill>
@@ -12127,7 +12127,7 @@
               </a:defRPr>
             </a:pPr>
             <a:r>
-              <a:t>• Challenge Scope: Flight envelope covers altitudes up to 12,053 m and speed up to 0.90 Mach. Rotor spool speeds run up to 80,941 RPM. Subsystem states degrade progressively over 30 cycles.</a:t>
+              <a:t>• Envelope: Speeds up to 80,941 RPM and altitudes up to 12,053 m; wear progresses over 30 cycles.</a:t>
             </a:r>
           </a:p>
         </p:txBody>
@@ -12657,7 +12657,7 @@
           </a:ln>
         </p:spPr>
         <p:txBody>
-          <a:bodyPr spcFirstLastPara="1" wrap="square" lIns="0" tIns="0" rIns="0" bIns="0" anchor="t" anchorCtr="0">
+          <a:bodyPr spcFirstLastPara="1" wrap="square" tIns="91440" bIns="91440" anchor="t" anchorCtr="0">
             <a:spAutoFit/>
           </a:bodyPr>
           <a:lstStyle/>
@@ -12670,7 +12670,7 @@
                 <a:spcPts val="0"/>
               </a:spcAft>
               <a:buNone/>
-              <a:defRPr sz="1800">
+              <a:defRPr sz="1100">
                 <a:solidFill>
                   <a:srgbClr val="475569"/>
                 </a:solidFill>
@@ -12678,13 +12678,13 @@
               </a:defRPr>
             </a:pPr>
             <a:r>
-              <a:t>• Traditional Data-Driven Models: Standard Machine Learning models (MLP, XGBoost) fit telemetry data but ignore physical laws. They are prone to predicting non-physical engine states under flight envelope transitions.</a:t>
+              <a:t>• Data-Driven Models: Standard ML (MLP, XGBoost) ignores physical laws and predicts non-physical states.</a:t>
             </a:r>
             <a:endParaRPr dirty="0"/>
           </a:p>
           <a:p>
             <a:pPr>
-              <a:defRPr sz="1800">
+              <a:defRPr sz="1100">
                 <a:solidFill>
                   <a:srgbClr val="475569"/>
                 </a:solidFill>
@@ -12692,12 +12692,12 @@
               </a:defRPr>
             </a:pPr>
             <a:r>
-              <a:t>• Constant Specific Heat Ratio Assumptions: Conventional textbook Thermodynamic models assume constant Specific Heat (gamma = 1.4), which fails above 1,000 K where air behaves as a calorically semi-perfect gas.</a:t>
+              <a:t>• Constant Heat Assumptions: Convention assumes gamma = 1.4, which fails above 1,000 K as gas properties change.</a:t>
             </a:r>
           </a:p>
           <a:p>
             <a:pPr>
-              <a:defRPr sz="1800">
+              <a:defRPr sz="1100">
                 <a:solidFill>
                   <a:srgbClr val="475569"/>
                 </a:solidFill>
@@ -12705,12 +12705,12 @@
               </a:defRPr>
             </a:pPr>
             <a:r>
-              <a:t>• High-Fidelity Simulation Models: Standard gas turbine transient simulation tools are highly accurate but computationally heavy, preventing real-time on-board edge diagnostics.</a:t>
+              <a:t>• Physics-Informed Neural Networks: Combines data-driven execution speed with thermodynamics constraints.</a:t>
             </a:r>
           </a:p>
           <a:p>
             <a:pPr>
-              <a:defRPr sz="1800">
+              <a:defRPr sz="1100">
                 <a:solidFill>
                   <a:srgbClr val="475569"/>
                 </a:solidFill>
@@ -12718,7 +12718,7 @@
               </a:defRPr>
             </a:pPr>
             <a:r>
-              <a:t>• Selected Framework: A Physics-Informed Neural Network (PINN) that integrates temperature-dependent gas dynamics (Cp(T) polynomials) to combine data-driven speed with thermodynamic consistency.</a:t>
+              <a:t>• Selected Framework: Grey-box PINN integrating temperature-dependent specific heats (Cp(T) polynomials).</a:t>
             </a:r>
           </a:p>
         </p:txBody>
@@ -13130,7 +13130,7 @@
           </a:ln>
         </p:spPr>
         <p:txBody>
-          <a:bodyPr spcFirstLastPara="1" wrap="square" lIns="0" tIns="0" rIns="0" bIns="0" anchor="t" anchorCtr="0">
+          <a:bodyPr spcFirstLastPara="1" wrap="square" tIns="91440" bIns="91440" anchor="t" anchorCtr="0">
             <a:spAutoFit/>
           </a:bodyPr>
           <a:lstStyle/>
@@ -13143,7 +13143,7 @@
                 <a:spcPts val="0"/>
               </a:spcAft>
               <a:buNone/>
-              <a:defRPr sz="1800">
+              <a:defRPr sz="1100">
                 <a:solidFill>
                   <a:srgbClr val="475569"/>
                 </a:solidFill>
@@ -13151,13 +13151,13 @@
               </a:defRPr>
             </a:pPr>
             <a:r>
-              <a:t>• Deep Learning Architecture: Multi-Layer Perceptron (MLP) mapping 13 inputs (sensors + Cycle) to 6 outputs (Health indexes, Thrust, TSFC).</a:t>
+              <a:t>• Architecture: 13-input MLP (sensors + cycle) -&gt; Dense layers -&gt; 6 outputs.</a:t>
             </a:r>
             <a:endParaRPr dirty="0"/>
           </a:p>
           <a:p>
             <a:pPr>
-              <a:defRPr sz="1800">
+              <a:defRPr sz="1100">
                 <a:solidFill>
                   <a:srgbClr val="475569"/>
                 </a:solidFill>
@@ -13165,12 +13165,12 @@
               </a:defRPr>
             </a:pPr>
             <a:r>
-              <a:t>• Calorically Semi-Perfect Gas Model: Evaluates specific heat ratio k(T) = R/Cp(T) dynamically at average compressor and turbine stage temperatures:</a:t>
+              <a:t>• Gas Dynamics: Computes Cp(T) dynamically at stage temperatures to model gas properties:</a:t>
             </a:r>
           </a:p>
           <a:p>
             <a:pPr>
-              <a:defRPr sz="1800">
+              <a:defRPr sz="1100">
                 <a:solidFill>
                   <a:srgbClr val="475569"/>
                 </a:solidFill>
@@ -13183,7 +13183,7 @@
           </a:p>
           <a:p>
             <a:pPr>
-              <a:defRPr sz="1800">
+              <a:defRPr sz="1100">
                 <a:solidFill>
                   <a:srgbClr val="475569"/>
                 </a:solidFill>
@@ -13191,12 +13191,12 @@
               </a:defRPr>
             </a:pPr>
             <a:r>
-              <a:t>• Physics-Regularized Loss: Enforces isentropic compressor temperature rises, isentropic turbine work extraction, and combustor pressure recovery ratio (P3/P2 = 0.949).</a:t>
+              <a:t>• Physics Losses: Enforces isentropic work limits and combustor pressure recovery ratio (P3/P2 = 0.949).</a:t>
             </a:r>
           </a:p>
           <a:p>
             <a:pPr>
-              <a:defRPr sz="1800">
+              <a:defRPr sz="1100">
                 <a:solidFill>
                   <a:srgbClr val="475569"/>
                 </a:solidFill>
@@ -13204,7 +13204,7 @@
               </a:defRPr>
             </a:pPr>
             <a:r>
-              <a:t>• Multi-Objective Optimization: Formulates loss as a combination of data loss, empirical health checks, and Brayton cycle constraints.</a:t>
+              <a:t>• Optimizer: Composite loss trained via Adam with Cosine Annealing learning rate schedule.</a:t>
             </a:r>
           </a:p>
         </p:txBody>
@@ -13616,7 +13616,7 @@
           </a:ln>
         </p:spPr>
         <p:txBody>
-          <a:bodyPr spcFirstLastPara="1" wrap="square" lIns="0" tIns="0" rIns="0" bIns="0" anchor="t" anchorCtr="0">
+          <a:bodyPr spcFirstLastPara="1" wrap="square" tIns="91440" bIns="91440" anchor="t" anchorCtr="0">
             <a:spAutoFit/>
           </a:bodyPr>
           <a:lstStyle/>
@@ -13629,7 +13629,7 @@
                 <a:spcPts val="0"/>
               </a:spcAft>
               <a:buNone/>
-              <a:defRPr sz="1800">
+              <a:defRPr sz="1100">
                 <a:solidFill>
                   <a:srgbClr val="475569"/>
                 </a:solidFill>
@@ -13637,13 +13637,13 @@
               </a:defRPr>
             </a:pPr>
             <a:r>
-              <a:t>• Data Source: HAL PS-2 synthetic flight telemetry dataset. Consists of 10 virtual engine fleets operating over 30 cycles.</a:t>
+              <a:t>• Data Source: HAL PS-2 synthetic telemetry (10 engine fleets tracked over 30 cycles).</a:t>
             </a:r>
             <a:endParaRPr dirty="0"/>
           </a:p>
           <a:p>
             <a:pPr>
-              <a:defRPr sz="1800">
+              <a:defRPr sz="1100">
                 <a:solidFill>
                   <a:srgbClr val="475569"/>
                 </a:solidFill>
@@ -13651,12 +13651,12 @@
               </a:defRPr>
             </a:pPr>
             <a:r>
-              <a:t>• Feature Engineering: Prepend Cycle (index 0) as the 13th feature to represent temporal wear progression.</a:t>
+              <a:t>• Cycle Feature: Prepended Cycle (index 0) to represent temporal wear progression.</a:t>
             </a:r>
           </a:p>
           <a:p>
             <a:pPr>
-              <a:defRPr sz="1800">
+              <a:defRPr sz="1100">
                 <a:solidFill>
                   <a:srgbClr val="475569"/>
                 </a:solidFill>
@@ -13664,12 +13664,12 @@
               </a:defRPr>
             </a:pPr>
             <a:r>
-              <a:t>• Scaling: Applied Standard Scaling to center inputs (X_mean, X_scale) and targets (y_mean, y_scale) around zero, ensuring balanced backpropagation gradient flow.</a:t>
+              <a:t>• Standard Scaling: Normalized inputs &amp; targets around zero to ensure balanced backpropagation gradients.</a:t>
             </a:r>
           </a:p>
           <a:p>
             <a:pPr>
-              <a:defRPr sz="1800">
+              <a:defRPr sz="1100">
                 <a:solidFill>
                   <a:srgbClr val="475569"/>
                 </a:solidFill>
@@ -13677,7 +13677,7 @@
               </a:defRPr>
             </a:pPr>
             <a:r>
-              <a:t>• Physics Unscaling: Scaling parameters are registered as PyTorch tensors to dynamically unscale parameters inside the custom loss module, allowing accurate physical laws evaluation.</a:t>
+              <a:t>• Unscaling Tensors: Restores physical units inside loss function to evaluate thermodynamics equations.</a:t>
             </a:r>
           </a:p>
         </p:txBody>
@@ -14089,7 +14089,7 @@
           </a:ln>
         </p:spPr>
         <p:txBody>
-          <a:bodyPr spcFirstLastPara="1" wrap="square" lIns="0" tIns="0" rIns="0" bIns="0" anchor="t" anchorCtr="0">
+          <a:bodyPr spcFirstLastPara="1" wrap="square" tIns="91440" bIns="91440" anchor="t" anchorCtr="0">
             <a:spAutoFit/>
           </a:bodyPr>
           <a:lstStyle/>
@@ -14102,7 +14102,7 @@
                 <a:spcPts val="0"/>
               </a:spcAft>
               <a:buNone/>
-              <a:defRPr sz="1800">
+              <a:defRPr sz="1100">
                 <a:solidFill>
                   <a:srgbClr val="475569"/>
                 </a:solidFill>
@@ -14110,13 +14110,13 @@
               </a:defRPr>
             </a:pPr>
             <a:r>
-              <a:t>• Training: Trained in PyTorch over 800 epochs with Adam optimizer and Cosine Annealing learning rate schedule.</a:t>
+              <a:t>• Training: Trained in PyTorch over 800 epochs.</a:t>
             </a:r>
             <a:endParaRPr dirty="0"/>
           </a:p>
           <a:p>
             <a:pPr>
-              <a:defRPr sz="1800">
+              <a:defRPr sz="1100">
                 <a:solidFill>
                   <a:srgbClr val="475569"/>
                 </a:solidFill>
@@ -14124,12 +14124,12 @@
               </a:defRPr>
             </a:pPr>
             <a:r>
-              <a:t>• Model Conversion: Extracted weights, biases, and scaling factors from PyTorch .pt file and exported them to JavaScript (weights.js).</a:t>
+              <a:t>• Model Conversion: Extracted weights, biases, and scaling factors from PyTorch .pt file to weights.js.</a:t>
             </a:r>
           </a:p>
           <a:p>
             <a:pPr>
-              <a:defRPr sz="1800">
+              <a:defRPr sz="1100">
                 <a:solidFill>
                   <a:srgbClr val="475569"/>
                 </a:solidFill>
@@ -14137,12 +14137,12 @@
               </a:defRPr>
             </a:pPr>
             <a:r>
-              <a:t>• Client-Side Execution: Neural network forward pass is computed directly in the user's browser using local matrix multiplication and Tanh activations.</a:t>
+              <a:t>• Client-Side Run: Network forward pass computed locally inside browser via Javascript.</a:t>
             </a:r>
           </a:p>
           <a:p>
             <a:pPr>
-              <a:defRPr sz="1800">
+              <a:defRPr sz="1100">
                 <a:solidFill>
                   <a:srgbClr val="475569"/>
                 </a:solidFill>
@@ -14150,7 +14150,7 @@
               </a:defRPr>
             </a:pPr>
             <a:r>
-              <a:t>• Hosting Strategy: 100% serverless, zero-config static site hosted on Netlify, requiring no backend python execution or database connections.</a:t>
+              <a:t>• Hosting Strategy: 100% serverless static website hosted on Netlify, requiring no backend server.</a:t>
             </a:r>
           </a:p>
         </p:txBody>
@@ -14489,11 +14489,11 @@
                 <a:spcPts val="0"/>
               </a:spcAft>
               <a:buNone/>
-              <a:defRPr sz="1350">
+              <a:defRPr sz="1400" b="1">
                 <a:solidFill>
-                  <a:srgbClr val="0369A1"/>
+                  <a:srgbClr val="FFFFFF"/>
                 </a:solidFill>
-                <a:latin typeface="Montserrat SemiBold"/>
+                <a:latin typeface="Outfit"/>
               </a:defRPr>
             </a:pPr>
             <a:r>
@@ -14536,137 +14536,580 @@
           </a:ln>
         </p:spPr>
       </p:pic>
-      <p:sp>
-        <p:nvSpPr>
-          <p:cNvPr id="4" name="Google Shape;102;p14">
-            <a:extLst>
-              <a:ext uri="{FF2B5EF4-FFF2-40B4-BE49-F238E27FC236}">
-                <a16:creationId xmlns:a16="http://schemas.microsoft.com/office/drawing/2014/main" id="{976FA8F7-DA2F-C0B8-E997-7A4E23985341}"/>
-              </a:ext>
-            </a:extLst>
-          </p:cNvPr>
-          <p:cNvSpPr txBox="1"/>
+      <p:graphicFrame>
+        <p:nvGraphicFramePr>
+          <p:cNvPr id="202" name="Table 201"/>
+          <p:cNvGraphicFramePr>
+            <a:graphicFrameLocks noGrp="1"/>
+          </p:cNvGraphicFramePr>
           <p:nvPr/>
-        </p:nvSpPr>
-        <p:spPr>
-          <a:xfrm>
-            <a:off x="1285875" y="2278380"/>
-            <a:ext cx="4308680" cy="276999"/>
-          </a:xfrm>
-          <a:prstGeom prst="rect">
-            <a:avLst/>
-          </a:prstGeom>
-          <a:noFill/>
-          <a:ln>
-            <a:noFill/>
-          </a:ln>
-        </p:spPr>
-        <p:txBody>
-          <a:bodyPr spcFirstLastPara="1" wrap="square" lIns="0" tIns="0" rIns="0" bIns="0" anchor="t" anchorCtr="0">
-            <a:spAutoFit/>
-          </a:bodyPr>
-          <a:lstStyle/>
-          <a:p>
-            <a:pPr marL="0" marR="0" lvl="0" indent="0" algn="l" rtl="0">
-              <a:spcBef>
-                <a:spcPts val="0"/>
-              </a:spcBef>
-              <a:spcAft>
-                <a:spcPts val="0"/>
-              </a:spcAft>
-              <a:buNone/>
-              <a:defRPr sz="1800">
-                <a:solidFill>
-                  <a:srgbClr val="475569"/>
-                </a:solidFill>
-                <a:latin typeface="Open Sans"/>
-              </a:defRPr>
-            </a:pPr>
-            <a:r>
-              <a:t>• Performance Metrics on Test Set:</a:t>
-            </a:r>
-            <a:endParaRPr dirty="0"/>
-          </a:p>
-          <a:p>
-            <a:pPr>
-              <a:defRPr sz="1800">
-                <a:solidFill>
-                  <a:srgbClr val="475569"/>
-                </a:solidFill>
-                <a:latin typeface="Open Sans"/>
-              </a:defRPr>
-            </a:pPr>
-            <a:r>
-              <a:t>  - CompressorHealth R2: 93.27% | CombustorHealth R2: 65.58% | TurbineHealth R2: 73.44%</a:t>
-            </a:r>
-          </a:p>
-          <a:p>
-            <a:pPr>
-              <a:defRPr sz="1800">
-                <a:solidFill>
-                  <a:srgbClr val="475569"/>
-                </a:solidFill>
-                <a:latin typeface="Open Sans"/>
-              </a:defRPr>
-            </a:pPr>
-            <a:r>
-              <a:t>  - OverallHealth R2: 95.15% | Thrust R2: 99.13% | TSFC R2: 99.25%</a:t>
-            </a:r>
-          </a:p>
-          <a:p>
-            <a:pPr>
-              <a:defRPr sz="1800">
-                <a:solidFill>
-                  <a:srgbClr val="475569"/>
-                </a:solidFill>
-                <a:latin typeface="Open Sans"/>
-              </a:defRPr>
-            </a:pPr>
-            <a:r>
-              <a:t>• Uncertainty Bounds (95% Confidence Interval from 1.96 * Validation RMSE):</a:t>
-            </a:r>
-          </a:p>
-          <a:p>
-            <a:pPr>
-              <a:defRPr sz="1800">
-                <a:solidFill>
-                  <a:srgbClr val="475569"/>
-                </a:solidFill>
-                <a:latin typeface="Open Sans"/>
-              </a:defRPr>
-            </a:pPr>
-            <a:r>
-              <a:t>  - Thrust: +/- 2,895 N | TSFC: +/- 0.0012 g/N/s</a:t>
-            </a:r>
-          </a:p>
-          <a:p>
-            <a:pPr>
-              <a:defRPr sz="1800">
-                <a:solidFill>
-                  <a:srgbClr val="475569"/>
-                </a:solidFill>
-                <a:latin typeface="Open Sans"/>
-              </a:defRPr>
-            </a:pPr>
-            <a:r>
-              <a:t>  - Compressor: +/- 3.8% | Combustor: +/- 3.4% | Turbine: +/- 4.8% | Overall: +/- 2.2%</a:t>
-            </a:r>
-          </a:p>
-          <a:p>
-            <a:pPr>
-              <a:defRPr sz="1800">
-                <a:solidFill>
-                  <a:srgbClr val="475569"/>
-                </a:solidFill>
-                <a:latin typeface="Open Sans"/>
-              </a:defRPr>
-            </a:pPr>
-            <a:r>
-              <a:t>• Dashboard Visualization: Dynamic progress dials displaying prediction outputs alongside confidence intervals.</a:t>
-            </a:r>
-          </a:p>
-        </p:txBody>
-      </p:sp>
+        </p:nvGraphicFramePr>
+        <p:xfrm>
+          <a:off x="1285875" y="2278380"/>
+          <a:ext cx="6400800" cy="276999"/>
+        </p:xfrm>
+        <a:graphic>
+          <a:graphicData uri="http://schemas.openxmlformats.org/drawingml/2006/table">
+            <a:tbl>
+              <a:tblPr firstRow="1" bandRow="1">
+                <a:tableStyleId>{5C22544A-7EE6-4342-B048-85BDC9FD1C3A}</a:tableStyleId>
+              </a:tblPr>
+              <a:tblGrid>
+                <a:gridCol w="2011680"/>
+                <a:gridCol w="1097280"/>
+                <a:gridCol w="1280160"/>
+                <a:gridCol w="2011680"/>
+              </a:tblGrid>
+              <a:tr h="39571">
+                <a:tc>
+                  <a:txBody>
+                    <a:bodyPr/>
+                    <a:lstStyle/>
+                    <a:p>
+                      <a:pPr algn="ctr">
+                        <a:defRPr b="1" sz="1100">
+                          <a:solidFill>
+                            <a:srgbClr val="22D3EE"/>
+                          </a:solidFill>
+                        </a:defRPr>
+                      </a:pPr>
+                      <a:r>
+                        <a:t>Metric Target</a:t>
+                      </a:r>
+                    </a:p>
+                  </a:txBody>
+                  <a:tcPr/>
+                </a:tc>
+                <a:tc>
+                  <a:txBody>
+                    <a:bodyPr/>
+                    <a:lstStyle/>
+                    <a:p>
+                      <a:pPr algn="ctr">
+                        <a:defRPr b="1" sz="1100">
+                          <a:solidFill>
+                            <a:srgbClr val="22D3EE"/>
+                          </a:solidFill>
+                        </a:defRPr>
+                      </a:pPr>
+                      <a:r>
+                        <a:t>RMSE</a:t>
+                      </a:r>
+                    </a:p>
+                  </a:txBody>
+                  <a:tcPr/>
+                </a:tc>
+                <a:tc>
+                  <a:txBody>
+                    <a:bodyPr/>
+                    <a:lstStyle/>
+                    <a:p>
+                      <a:pPr algn="ctr">
+                        <a:defRPr b="1" sz="1100">
+                          <a:solidFill>
+                            <a:srgbClr val="22D3EE"/>
+                          </a:solidFill>
+                        </a:defRPr>
+                      </a:pPr>
+                      <a:r>
+                        <a:t>R² Score</a:t>
+                      </a:r>
+                    </a:p>
+                  </a:txBody>
+                  <a:tcPr/>
+                </a:tc>
+                <a:tc>
+                  <a:txBody>
+                    <a:bodyPr/>
+                    <a:lstStyle/>
+                    <a:p>
+                      <a:pPr algn="ctr">
+                        <a:defRPr b="1" sz="1100">
+                          <a:solidFill>
+                            <a:srgbClr val="22D3EE"/>
+                          </a:solidFill>
+                        </a:defRPr>
+                      </a:pPr>
+                      <a:r>
+                        <a:t>95% Confidence Interval</a:t>
+                      </a:r>
+                    </a:p>
+                  </a:txBody>
+                  <a:tcPr/>
+                </a:tc>
+              </a:tr>
+              <a:tr h="39571">
+                <a:tc>
+                  <a:txBody>
+                    <a:bodyPr/>
+                    <a:lstStyle/>
+                    <a:p>
+                      <a:pPr algn="l">
+                        <a:defRPr sz="1000">
+                          <a:solidFill>
+                            <a:srgbClr val="FFFFFF"/>
+                          </a:solidFill>
+                        </a:defRPr>
+                      </a:pPr>
+                      <a:r>
+                        <a:t>CompressorHealth</a:t>
+                      </a:r>
+                    </a:p>
+                  </a:txBody>
+                  <a:tcPr/>
+                </a:tc>
+                <a:tc>
+                  <a:txBody>
+                    <a:bodyPr/>
+                    <a:lstStyle/>
+                    <a:p>
+                      <a:pPr algn="ctr">
+                        <a:defRPr sz="1000">
+                          <a:solidFill>
+                            <a:srgbClr val="FFFFFF"/>
+                          </a:solidFill>
+                        </a:defRPr>
+                      </a:pPr>
+                      <a:r>
+                        <a:t>0.0195</a:t>
+                      </a:r>
+                    </a:p>
+                  </a:txBody>
+                  <a:tcPr/>
+                </a:tc>
+                <a:tc>
+                  <a:txBody>
+                    <a:bodyPr/>
+                    <a:lstStyle/>
+                    <a:p>
+                      <a:pPr algn="ctr">
+                        <a:defRPr sz="1000">
+                          <a:solidFill>
+                            <a:srgbClr val="FFFFFF"/>
+                          </a:solidFill>
+                        </a:defRPr>
+                      </a:pPr>
+                      <a:r>
+                        <a:t>93.27%</a:t>
+                      </a:r>
+                    </a:p>
+                  </a:txBody>
+                  <a:tcPr/>
+                </a:tc>
+                <a:tc>
+                  <a:txBody>
+                    <a:bodyPr/>
+                    <a:lstStyle/>
+                    <a:p>
+                      <a:pPr algn="ctr">
+                        <a:defRPr sz="1000">
+                          <a:solidFill>
+                            <a:srgbClr val="FFFFFF"/>
+                          </a:solidFill>
+                        </a:defRPr>
+                      </a:pPr>
+                      <a:r>
+                        <a:t>± 3.80%</a:t>
+                      </a:r>
+                    </a:p>
+                  </a:txBody>
+                  <a:tcPr/>
+                </a:tc>
+              </a:tr>
+              <a:tr h="39571">
+                <a:tc>
+                  <a:txBody>
+                    <a:bodyPr/>
+                    <a:lstStyle/>
+                    <a:p>
+                      <a:pPr algn="l">
+                        <a:defRPr sz="1000">
+                          <a:solidFill>
+                            <a:srgbClr val="FFFFFF"/>
+                          </a:solidFill>
+                        </a:defRPr>
+                      </a:pPr>
+                      <a:r>
+                        <a:t>CombustorHealth</a:t>
+                      </a:r>
+                    </a:p>
+                  </a:txBody>
+                  <a:tcPr/>
+                </a:tc>
+                <a:tc>
+                  <a:txBody>
+                    <a:bodyPr/>
+                    <a:lstStyle/>
+                    <a:p>
+                      <a:pPr algn="ctr">
+                        <a:defRPr sz="1000">
+                          <a:solidFill>
+                            <a:srgbClr val="FFFFFF"/>
+                          </a:solidFill>
+                        </a:defRPr>
+                      </a:pPr>
+                      <a:r>
+                        <a:t>0.0174</a:t>
+                      </a:r>
+                    </a:p>
+                  </a:txBody>
+                  <a:tcPr/>
+                </a:tc>
+                <a:tc>
+                  <a:txBody>
+                    <a:bodyPr/>
+                    <a:lstStyle/>
+                    <a:p>
+                      <a:pPr algn="ctr">
+                        <a:defRPr sz="1000">
+                          <a:solidFill>
+                            <a:srgbClr val="FFFFFF"/>
+                          </a:solidFill>
+                        </a:defRPr>
+                      </a:pPr>
+                      <a:r>
+                        <a:t>65.58%</a:t>
+                      </a:r>
+                    </a:p>
+                  </a:txBody>
+                  <a:tcPr/>
+                </a:tc>
+                <a:tc>
+                  <a:txBody>
+                    <a:bodyPr/>
+                    <a:lstStyle/>
+                    <a:p>
+                      <a:pPr algn="ctr">
+                        <a:defRPr sz="1000">
+                          <a:solidFill>
+                            <a:srgbClr val="FFFFFF"/>
+                          </a:solidFill>
+                        </a:defRPr>
+                      </a:pPr>
+                      <a:r>
+                        <a:t>± 3.40%</a:t>
+                      </a:r>
+                    </a:p>
+                  </a:txBody>
+                  <a:tcPr/>
+                </a:tc>
+              </a:tr>
+              <a:tr h="39571">
+                <a:tc>
+                  <a:txBody>
+                    <a:bodyPr/>
+                    <a:lstStyle/>
+                    <a:p>
+                      <a:pPr algn="l">
+                        <a:defRPr sz="1000">
+                          <a:solidFill>
+                            <a:srgbClr val="FFFFFF"/>
+                          </a:solidFill>
+                        </a:defRPr>
+                      </a:pPr>
+                      <a:r>
+                        <a:t>TurbineHealth</a:t>
+                      </a:r>
+                    </a:p>
+                  </a:txBody>
+                  <a:tcPr/>
+                </a:tc>
+                <a:tc>
+                  <a:txBody>
+                    <a:bodyPr/>
+                    <a:lstStyle/>
+                    <a:p>
+                      <a:pPr algn="ctr">
+                        <a:defRPr sz="1000">
+                          <a:solidFill>
+                            <a:srgbClr val="FFFFFF"/>
+                          </a:solidFill>
+                        </a:defRPr>
+                      </a:pPr>
+                      <a:r>
+                        <a:t>0.0247</a:t>
+                      </a:r>
+                    </a:p>
+                  </a:txBody>
+                  <a:tcPr/>
+                </a:tc>
+                <a:tc>
+                  <a:txBody>
+                    <a:bodyPr/>
+                    <a:lstStyle/>
+                    <a:p>
+                      <a:pPr algn="ctr">
+                        <a:defRPr sz="1000">
+                          <a:solidFill>
+                            <a:srgbClr val="FFFFFF"/>
+                          </a:solidFill>
+                        </a:defRPr>
+                      </a:pPr>
+                      <a:r>
+                        <a:t>73.44%</a:t>
+                      </a:r>
+                    </a:p>
+                  </a:txBody>
+                  <a:tcPr/>
+                </a:tc>
+                <a:tc>
+                  <a:txBody>
+                    <a:bodyPr/>
+                    <a:lstStyle/>
+                    <a:p>
+                      <a:pPr algn="ctr">
+                        <a:defRPr sz="1000">
+                          <a:solidFill>
+                            <a:srgbClr val="FFFFFF"/>
+                          </a:solidFill>
+                        </a:defRPr>
+                      </a:pPr>
+                      <a:r>
+                        <a:t>± 4.80%</a:t>
+                      </a:r>
+                    </a:p>
+                  </a:txBody>
+                  <a:tcPr/>
+                </a:tc>
+              </a:tr>
+              <a:tr h="39571">
+                <a:tc>
+                  <a:txBody>
+                    <a:bodyPr/>
+                    <a:lstStyle/>
+                    <a:p>
+                      <a:pPr algn="l">
+                        <a:defRPr sz="1000">
+                          <a:solidFill>
+                            <a:srgbClr val="FFFFFF"/>
+                          </a:solidFill>
+                        </a:defRPr>
+                      </a:pPr>
+                      <a:r>
+                        <a:t>OverallHealth</a:t>
+                      </a:r>
+                    </a:p>
+                  </a:txBody>
+                  <a:tcPr/>
+                </a:tc>
+                <a:tc>
+                  <a:txBody>
+                    <a:bodyPr/>
+                    <a:lstStyle/>
+                    <a:p>
+                      <a:pPr algn="ctr">
+                        <a:defRPr sz="1000">
+                          <a:solidFill>
+                            <a:srgbClr val="FFFFFF"/>
+                          </a:solidFill>
+                        </a:defRPr>
+                      </a:pPr>
+                      <a:r>
+                        <a:t>0.0113</a:t>
+                      </a:r>
+                    </a:p>
+                  </a:txBody>
+                  <a:tcPr/>
+                </a:tc>
+                <a:tc>
+                  <a:txBody>
+                    <a:bodyPr/>
+                    <a:lstStyle/>
+                    <a:p>
+                      <a:pPr algn="ctr">
+                        <a:defRPr sz="1000">
+                          <a:solidFill>
+                            <a:srgbClr val="FFFFFF"/>
+                          </a:solidFill>
+                        </a:defRPr>
+                      </a:pPr>
+                      <a:r>
+                        <a:t>95.15%</a:t>
+                      </a:r>
+                    </a:p>
+                  </a:txBody>
+                  <a:tcPr/>
+                </a:tc>
+                <a:tc>
+                  <a:txBody>
+                    <a:bodyPr/>
+                    <a:lstStyle/>
+                    <a:p>
+                      <a:pPr algn="ctr">
+                        <a:defRPr sz="1000">
+                          <a:solidFill>
+                            <a:srgbClr val="FFFFFF"/>
+                          </a:solidFill>
+                        </a:defRPr>
+                      </a:pPr>
+                      <a:r>
+                        <a:t>± 2.20%</a:t>
+                      </a:r>
+                    </a:p>
+                  </a:txBody>
+                  <a:tcPr/>
+                </a:tc>
+              </a:tr>
+              <a:tr h="39571">
+                <a:tc>
+                  <a:txBody>
+                    <a:bodyPr/>
+                    <a:lstStyle/>
+                    <a:p>
+                      <a:pPr algn="l">
+                        <a:defRPr sz="1000">
+                          <a:solidFill>
+                            <a:srgbClr val="FFFFFF"/>
+                          </a:solidFill>
+                        </a:defRPr>
+                      </a:pPr>
+                      <a:r>
+                        <a:t>Engine Thrust</a:t>
+                      </a:r>
+                    </a:p>
+                  </a:txBody>
+                  <a:tcPr/>
+                </a:tc>
+                <a:tc>
+                  <a:txBody>
+                    <a:bodyPr/>
+                    <a:lstStyle/>
+                    <a:p>
+                      <a:pPr algn="ctr">
+                        <a:defRPr sz="1000">
+                          <a:solidFill>
+                            <a:srgbClr val="FFFFFF"/>
+                          </a:solidFill>
+                        </a:defRPr>
+                      </a:pPr>
+                      <a:r>
+                        <a:t>1476.8 N</a:t>
+                      </a:r>
+                    </a:p>
+                  </a:txBody>
+                  <a:tcPr/>
+                </a:tc>
+                <a:tc>
+                  <a:txBody>
+                    <a:bodyPr/>
+                    <a:lstStyle/>
+                    <a:p>
+                      <a:pPr algn="ctr">
+                        <a:defRPr sz="1000">
+                          <a:solidFill>
+                            <a:srgbClr val="FFFFFF"/>
+                          </a:solidFill>
+                        </a:defRPr>
+                      </a:pPr>
+                      <a:r>
+                        <a:t>99.13%</a:t>
+                      </a:r>
+                    </a:p>
+                  </a:txBody>
+                  <a:tcPr/>
+                </a:tc>
+                <a:tc>
+                  <a:txBody>
+                    <a:bodyPr/>
+                    <a:lstStyle/>
+                    <a:p>
+                      <a:pPr algn="ctr">
+                        <a:defRPr sz="1000">
+                          <a:solidFill>
+                            <a:srgbClr val="FFFFFF"/>
+                          </a:solidFill>
+                        </a:defRPr>
+                      </a:pPr>
+                      <a:r>
+                        <a:t>± 2,895 N</a:t>
+                      </a:r>
+                    </a:p>
+                  </a:txBody>
+                  <a:tcPr/>
+                </a:tc>
+              </a:tr>
+              <a:tr h="39573">
+                <a:tc>
+                  <a:txBody>
+                    <a:bodyPr/>
+                    <a:lstStyle/>
+                    <a:p>
+                      <a:pPr algn="l">
+                        <a:defRPr sz="1000">
+                          <a:solidFill>
+                            <a:srgbClr val="FFFFFF"/>
+                          </a:solidFill>
+                        </a:defRPr>
+                      </a:pPr>
+                      <a:r>
+                        <a:t>TSFC</a:t>
+                      </a:r>
+                    </a:p>
+                  </a:txBody>
+                  <a:tcPr/>
+                </a:tc>
+                <a:tc>
+                  <a:txBody>
+                    <a:bodyPr/>
+                    <a:lstStyle/>
+                    <a:p>
+                      <a:pPr algn="ctr">
+                        <a:defRPr sz="1000">
+                          <a:solidFill>
+                            <a:srgbClr val="FFFFFF"/>
+                          </a:solidFill>
+                        </a:defRPr>
+                      </a:pPr>
+                      <a:r>
+                        <a:t>0.0006</a:t>
+                      </a:r>
+                    </a:p>
+                  </a:txBody>
+                  <a:tcPr/>
+                </a:tc>
+                <a:tc>
+                  <a:txBody>
+                    <a:bodyPr/>
+                    <a:lstStyle/>
+                    <a:p>
+                      <a:pPr algn="ctr">
+                        <a:defRPr sz="1000">
+                          <a:solidFill>
+                            <a:srgbClr val="FFFFFF"/>
+                          </a:solidFill>
+                        </a:defRPr>
+                      </a:pPr>
+                      <a:r>
+                        <a:t>99.25%</a:t>
+                      </a:r>
+                    </a:p>
+                  </a:txBody>
+                  <a:tcPr/>
+                </a:tc>
+                <a:tc>
+                  <a:txBody>
+                    <a:bodyPr/>
+                    <a:lstStyle/>
+                    <a:p>
+                      <a:pPr algn="ctr">
+                        <a:defRPr sz="1000">
+                          <a:solidFill>
+                            <a:srgbClr val="FFFFFF"/>
+                          </a:solidFill>
+                        </a:defRPr>
+                      </a:pPr>
+                      <a:r>
+                        <a:t>± 0.0012 g/N/s</a:t>
+                      </a:r>
+                    </a:p>
+                  </a:txBody>
+                  <a:tcPr/>
+                </a:tc>
+              </a:tr>
+            </a:tbl>
+          </a:graphicData>
+        </a:graphic>
+      </p:graphicFrame>
     </p:spTree>
   </p:cSld>
   <p:clrMapOvr>
@@ -15074,7 +15517,7 @@
           </a:ln>
         </p:spPr>
         <p:txBody>
-          <a:bodyPr spcFirstLastPara="1" wrap="square" lIns="0" tIns="0" rIns="0" bIns="0" anchor="t" anchorCtr="0">
+          <a:bodyPr spcFirstLastPara="1" wrap="square" tIns="91440" bIns="91440" anchor="t" anchorCtr="0">
             <a:spAutoFit/>
           </a:bodyPr>
           <a:lstStyle/>
@@ -15087,7 +15530,7 @@
                 <a:spcPts val="0"/>
               </a:spcAft>
               <a:buNone/>
-              <a:defRPr sz="1800">
+              <a:defRPr sz="1100">
                 <a:solidFill>
                   <a:srgbClr val="475569"/>
                 </a:solidFill>
@@ -15095,13 +15538,13 @@
               </a:defRPr>
             </a:pPr>
             <a:r>
-              <a:t>• Sudais Farooq - Project Lead &amp; Core Engineer: Developed the PyTorch PINN model, implemented the calorically semi-perfect gas thermodynamics loss functions, and compiled the training pipeline.</a:t>
+              <a:t>• Sudais Farooq - Project Lead &amp; Core Engineer: Developed PyTorch PINN model &amp; loss function.</a:t>
             </a:r>
             <a:endParaRPr dirty="0"/>
           </a:p>
           <a:p>
             <a:pPr>
-              <a:defRPr sz="1800">
+              <a:defRPr sz="1100">
                 <a:solidFill>
                   <a:srgbClr val="475569"/>
                 </a:solidFill>
@@ -15109,12 +15552,12 @@
               </a:defRPr>
             </a:pPr>
             <a:r>
-              <a:t>• Front-End Developer: Designed the widescreen HUD-themed glassmorphism dashboard, and implemented the browser-based matrix multiplier model runner.</a:t>
+              <a:t>• Front-End Developer: Built HUD dashboard &amp; client-side matrix math runner.</a:t>
             </a:r>
           </a:p>
           <a:p>
             <a:pPr>
-              <a:defRPr sz="1800">
+              <a:defRPr sz="1100">
                 <a:solidFill>
                   <a:srgbClr val="475569"/>
                 </a:solidFill>
@@ -15122,7 +15565,7 @@
               </a:defRPr>
             </a:pPr>
             <a:r>
-              <a:t>• QA / System Deployer: Configured the local Express server, and prepared the Netlify static hosting deployment configurations.</a:t>
+              <a:t>• QA &amp; Deployment: Configured local Express server &amp; Netlify static hosting.</a:t>
             </a:r>
           </a:p>
         </p:txBody>
@@ -15472,7 +15915,7 @@
           </a:ln>
         </p:spPr>
         <p:txBody>
-          <a:bodyPr spcFirstLastPara="1" wrap="square" lIns="0" tIns="0" rIns="0" bIns="0" anchor="t" anchorCtr="0">
+          <a:bodyPr spcFirstLastPara="1" wrap="square" tIns="91440" bIns="91440" anchor="t" anchorCtr="0">
             <a:spAutoFit/>
           </a:bodyPr>
           <a:lstStyle/>
@@ -15485,7 +15928,7 @@
                 <a:spcPts val="0"/>
               </a:spcAft>
               <a:buNone/>
-              <a:defRPr sz="1800">
+              <a:defRPr sz="1100">
                 <a:solidFill>
                   <a:srgbClr val="475569"/>
                 </a:solidFill>
@@ -15493,13 +15936,13 @@
               </a:defRPr>
             </a:pPr>
             <a:r>
-              <a:t>• Reference 1: Challenge specifications and flight envelopes defined in HAL-IIT Indore Hackathon Problem Statement 2 (PS 2) pages.</a:t>
+              <a:t>• Reference 1: HAL-IIT Indore Hackathon Problem Statement 2 (PS 2) specifications.</a:t>
             </a:r>
             <a:endParaRPr dirty="0"/>
           </a:p>
           <a:p>
             <a:pPr>
-              <a:defRPr sz="1800">
+              <a:defRPr sz="1100">
                 <a:solidFill>
                   <a:srgbClr val="475569"/>
                 </a:solidFill>
@@ -15507,12 +15950,12 @@
               </a:defRPr>
             </a:pPr>
             <a:r>
-              <a:t>• Reference 2: Hill, P. G., &amp; Peterson, C. R., 'Mechanics and Thermodynamics of Propulsion', 2nd Edition.</a:t>
+              <a:t>• Reference 2: Hill &amp; Peterson, 'Mechanics and Thermodynamics of Propulsion', 2nd Edition.</a:t>
             </a:r>
           </a:p>
           <a:p>
             <a:pPr>
-              <a:defRPr sz="1800">
+              <a:defRPr sz="1100">
                 <a:solidFill>
                   <a:srgbClr val="475569"/>
                 </a:solidFill>
@@ -15520,12 +15963,12 @@
               </a:defRPr>
             </a:pPr>
             <a:r>
-              <a:t>• Project Repository: https://github.com/SudaisFarooq/Aerothon</a:t>
+              <a:t>• Code Repository: https://github.com/SudaisFarooq/Aerothon</a:t>
             </a:r>
           </a:p>
           <a:p>
             <a:pPr>
-              <a:defRPr sz="1800">
+              <a:defRPr sz="1100">
                 <a:solidFill>
                   <a:srgbClr val="475569"/>
                 </a:solidFill>
@@ -15533,7 +15976,7 @@
               </a:defRPr>
             </a:pPr>
             <a:r>
-              <a:t>• Live Web Application URL: https://github.com/SudaisFarooq/Aerothon</a:t>
+              <a:t>• Live Web App URL: https://github.com/SudaisFarooq/Aerothon</a:t>
             </a:r>
           </a:p>
         </p:txBody>

</xml_diff>